<commit_message>
edits to chapter 9
</commit_message>
<xml_diff>
--- a/Lecture_Slides/PH 123 Lecture 09.pptx
+++ b/Lecture_Slides/PH 123 Lecture 09.pptx
@@ -147,25 +147,48 @@
 <pc:chgInfo xmlns:a="http://schemas.openxmlformats.org/drawingml/2006/main" xmlns:r="http://schemas.openxmlformats.org/officeDocument/2006/relationships" xmlns:ac="http://schemas.microsoft.com/office/drawing/2013/main/command" xmlns:pc="http://schemas.microsoft.com/office/powerpoint/2013/main/command">
   <pc:docChgLst>
     <pc:chgData name="Todd Lines" userId="afaf7c3a-e8aa-4568-882a-02ad8f9e19b0" providerId="ADAL" clId="{5FF5AC1B-ABA9-43D7-A1E3-2D92732CD6E2}"/>
-    <pc:docChg chg="modSld">
-      <pc:chgData name="Todd Lines" userId="afaf7c3a-e8aa-4568-882a-02ad8f9e19b0" providerId="ADAL" clId="{5FF5AC1B-ABA9-43D7-A1E3-2D92732CD6E2}" dt="2026-08-26T18:54:22.037" v="2" actId="20577"/>
+    <pc:docChg chg="custSel modSld">
+      <pc:chgData name="Todd Lines" userId="afaf7c3a-e8aa-4568-882a-02ad8f9e19b0" providerId="ADAL" clId="{5FF5AC1B-ABA9-43D7-A1E3-2D92732CD6E2}" dt="2026-09-29T17:16:15.321" v="11" actId="21"/>
       <pc:docMkLst>
         <pc:docMk/>
       </pc:docMkLst>
-      <pc:sldChg chg="modSp mod">
-        <pc:chgData name="Todd Lines" userId="afaf7c3a-e8aa-4568-882a-02ad8f9e19b0" providerId="ADAL" clId="{5FF5AC1B-ABA9-43D7-A1E3-2D92732CD6E2}" dt="2026-08-26T18:54:22.037" v="2" actId="20577"/>
+      <pc:sldChg chg="addSp delSp modSp mod">
+        <pc:chgData name="Todd Lines" userId="afaf7c3a-e8aa-4568-882a-02ad8f9e19b0" providerId="ADAL" clId="{5FF5AC1B-ABA9-43D7-A1E3-2D92732CD6E2}" dt="2026-09-29T17:15:48.668" v="8" actId="21"/>
         <pc:sldMkLst>
           <pc:docMk/>
-          <pc:sldMk cId="2630690811" sldId="293"/>
+          <pc:sldMk cId="0" sldId="267"/>
         </pc:sldMkLst>
-        <pc:spChg chg="mod">
-          <ac:chgData name="Todd Lines" userId="afaf7c3a-e8aa-4568-882a-02ad8f9e19b0" providerId="ADAL" clId="{5FF5AC1B-ABA9-43D7-A1E3-2D92732CD6E2}" dt="2026-08-26T18:54:22.037" v="2" actId="20577"/>
-          <ac:spMkLst>
+        <pc:picChg chg="add del mod">
+          <ac:chgData name="Todd Lines" userId="afaf7c3a-e8aa-4568-882a-02ad8f9e19b0" providerId="ADAL" clId="{5FF5AC1B-ABA9-43D7-A1E3-2D92732CD6E2}" dt="2026-09-29T17:15:32.300" v="5" actId="21"/>
+          <ac:picMkLst>
             <pc:docMk/>
-            <pc:sldMk cId="2630690811" sldId="293"/>
-            <ac:spMk id="2" creationId="{48677102-2D8F-05F0-C316-945DA29AB7BC}"/>
-          </ac:spMkLst>
-        </pc:spChg>
+            <pc:sldMk cId="0" sldId="267"/>
+            <ac:picMk id="5" creationId="{C6A39308-D40C-EF7C-D923-77CF60EE4087}"/>
+          </ac:picMkLst>
+        </pc:picChg>
+        <pc:picChg chg="add del mod">
+          <ac:chgData name="Todd Lines" userId="afaf7c3a-e8aa-4568-882a-02ad8f9e19b0" providerId="ADAL" clId="{5FF5AC1B-ABA9-43D7-A1E3-2D92732CD6E2}" dt="2026-09-29T17:15:48.668" v="8" actId="21"/>
+          <ac:picMkLst>
+            <pc:docMk/>
+            <pc:sldMk cId="0" sldId="267"/>
+            <ac:picMk id="7" creationId="{5646AB2E-CB7F-322E-BCE7-FD085403AA3D}"/>
+          </ac:picMkLst>
+        </pc:picChg>
+      </pc:sldChg>
+      <pc:sldChg chg="addSp delSp modSp mod">
+        <pc:chgData name="Todd Lines" userId="afaf7c3a-e8aa-4568-882a-02ad8f9e19b0" providerId="ADAL" clId="{5FF5AC1B-ABA9-43D7-A1E3-2D92732CD6E2}" dt="2026-09-29T17:16:15.321" v="11" actId="21"/>
+        <pc:sldMkLst>
+          <pc:docMk/>
+          <pc:sldMk cId="0" sldId="268"/>
+        </pc:sldMkLst>
+        <pc:picChg chg="add del mod">
+          <ac:chgData name="Todd Lines" userId="afaf7c3a-e8aa-4568-882a-02ad8f9e19b0" providerId="ADAL" clId="{5FF5AC1B-ABA9-43D7-A1E3-2D92732CD6E2}" dt="2026-09-29T17:16:15.321" v="11" actId="21"/>
+          <ac:picMkLst>
+            <pc:docMk/>
+            <pc:sldMk cId="0" sldId="268"/>
+            <ac:picMk id="3" creationId="{62E52D13-07F4-30EE-9CDC-D2618834A37E}"/>
+          </ac:picMkLst>
+        </pc:picChg>
       </pc:sldChg>
     </pc:docChg>
   </pc:docChgLst>
@@ -254,7 +277,7 @@
           <a:p>
             <a:fld id="{DDC20DDF-410A-4A2E-BE2B-BF9258AB4EBC}" type="datetimeFigureOut">
               <a:rPr lang="en-US" smtClean="0"/>
-              <a:t>8/26/2026</a:t>
+              <a:t>9/29/2026</a:t>
             </a:fld>
             <a:endParaRPr lang="en-US"/>
           </a:p>
@@ -815,7 +838,7 @@
             <a:fld id="{770D32CF-726D-406C-8E04-892C32375105}" type="datetimeFigureOut">
               <a:rPr lang="en-US" smtClean="0"/>
               <a:pPr/>
-              <a:t>8/26/2026</a:t>
+              <a:t>9/29/2026</a:t>
             </a:fld>
             <a:endParaRPr lang="en-US"/>
           </a:p>
@@ -980,7 +1003,7 @@
             <a:fld id="{770D32CF-726D-406C-8E04-892C32375105}" type="datetimeFigureOut">
               <a:rPr lang="en-US" smtClean="0"/>
               <a:pPr/>
-              <a:t>8/26/2026</a:t>
+              <a:t>9/29/2026</a:t>
             </a:fld>
             <a:endParaRPr lang="en-US"/>
           </a:p>
@@ -1155,7 +1178,7 @@
             <a:fld id="{770D32CF-726D-406C-8E04-892C32375105}" type="datetimeFigureOut">
               <a:rPr lang="en-US" smtClean="0"/>
               <a:pPr/>
-              <a:t>8/26/2026</a:t>
+              <a:t>9/29/2026</a:t>
             </a:fld>
             <a:endParaRPr lang="en-US"/>
           </a:p>
@@ -1320,7 +1343,7 @@
             <a:fld id="{770D32CF-726D-406C-8E04-892C32375105}" type="datetimeFigureOut">
               <a:rPr lang="en-US" smtClean="0"/>
               <a:pPr/>
-              <a:t>8/26/2026</a:t>
+              <a:t>9/29/2026</a:t>
             </a:fld>
             <a:endParaRPr lang="en-US"/>
           </a:p>
@@ -1562,7 +1585,7 @@
             <a:fld id="{770D32CF-726D-406C-8E04-892C32375105}" type="datetimeFigureOut">
               <a:rPr lang="en-US" smtClean="0"/>
               <a:pPr/>
-              <a:t>8/26/2026</a:t>
+              <a:t>9/29/2026</a:t>
             </a:fld>
             <a:endParaRPr lang="en-US"/>
           </a:p>
@@ -1844,7 +1867,7 @@
             <a:fld id="{770D32CF-726D-406C-8E04-892C32375105}" type="datetimeFigureOut">
               <a:rPr lang="en-US" smtClean="0"/>
               <a:pPr/>
-              <a:t>8/26/2026</a:t>
+              <a:t>9/29/2026</a:t>
             </a:fld>
             <a:endParaRPr lang="en-US"/>
           </a:p>
@@ -2260,7 +2283,7 @@
             <a:fld id="{770D32CF-726D-406C-8E04-892C32375105}" type="datetimeFigureOut">
               <a:rPr lang="en-US" smtClean="0"/>
               <a:pPr/>
-              <a:t>8/26/2026</a:t>
+              <a:t>9/29/2026</a:t>
             </a:fld>
             <a:endParaRPr lang="en-US"/>
           </a:p>
@@ -2374,7 +2397,7 @@
             <a:fld id="{770D32CF-726D-406C-8E04-892C32375105}" type="datetimeFigureOut">
               <a:rPr lang="en-US" smtClean="0"/>
               <a:pPr/>
-              <a:t>8/26/2026</a:t>
+              <a:t>9/29/2026</a:t>
             </a:fld>
             <a:endParaRPr lang="en-US"/>
           </a:p>
@@ -2466,7 +2489,7 @@
             <a:fld id="{770D32CF-726D-406C-8E04-892C32375105}" type="datetimeFigureOut">
               <a:rPr lang="en-US" smtClean="0"/>
               <a:pPr/>
-              <a:t>8/26/2026</a:t>
+              <a:t>9/29/2026</a:t>
             </a:fld>
             <a:endParaRPr lang="en-US"/>
           </a:p>
@@ -2738,7 +2761,7 @@
             <a:fld id="{770D32CF-726D-406C-8E04-892C32375105}" type="datetimeFigureOut">
               <a:rPr lang="en-US" smtClean="0"/>
               <a:pPr/>
-              <a:t>8/26/2026</a:t>
+              <a:t>9/29/2026</a:t>
             </a:fld>
             <a:endParaRPr lang="en-US"/>
           </a:p>
@@ -2987,7 +3010,7 @@
             <a:fld id="{770D32CF-726D-406C-8E04-892C32375105}" type="datetimeFigureOut">
               <a:rPr lang="en-US" smtClean="0"/>
               <a:pPr/>
-              <a:t>8/26/2026</a:t>
+              <a:t>9/29/2026</a:t>
             </a:fld>
             <a:endParaRPr lang="en-US"/>
           </a:p>
@@ -3195,7 +3218,7 @@
             <a:fld id="{770D32CF-726D-406C-8E04-892C32375105}" type="datetimeFigureOut">
               <a:rPr lang="en-US" smtClean="0"/>
               <a:pPr/>
-              <a:t>8/26/2026</a:t>
+              <a:t>9/29/2026</a:t>
             </a:fld>
             <a:endParaRPr lang="en-US"/>
           </a:p>

</xml_diff>